<commit_message>
Fill in week-11 practice_step1/step2 solutions; update slides
Co-Authored-By: Claude Opus 4.7 (1M context) <noreply@anthropic.com>
</commit_message>
<xml_diff>
--- a/week-11-web_app_development_with_streamlit/week-11-slides_v2.pptx
+++ b/week-11-web_app_development_with_streamlit/week-11-slides_v2.pptx
@@ -341,7 +341,7 @@
           <a:p>
             <a:fld id="{5BCAD085-E8A6-8845-BD4E-CB4CCA059FC4}" type="datetimeFigureOut">
               <a:rPr lang="en-US" smtClean="0"/>
-              <a:t>5/6/2026</a:t>
+              <a:t>5/7/2026</a:t>
             </a:fld>
             <a:endParaRPr lang="en-US"/>
           </a:p>
@@ -509,7 +509,7 @@
           <a:p>
             <a:fld id="{5BCAD085-E8A6-8845-BD4E-CB4CCA059FC4}" type="datetimeFigureOut">
               <a:rPr lang="en-US" smtClean="0"/>
-              <a:t>5/6/2026</a:t>
+              <a:t>5/7/2026</a:t>
             </a:fld>
             <a:endParaRPr lang="en-US"/>
           </a:p>
@@ -687,7 +687,7 @@
           <a:p>
             <a:fld id="{5BCAD085-E8A6-8845-BD4E-CB4CCA059FC4}" type="datetimeFigureOut">
               <a:rPr lang="en-US" smtClean="0"/>
-              <a:t>5/6/2026</a:t>
+              <a:t>5/7/2026</a:t>
             </a:fld>
             <a:endParaRPr lang="en-US"/>
           </a:p>
@@ -855,7 +855,7 @@
           <a:p>
             <a:fld id="{5BCAD085-E8A6-8845-BD4E-CB4CCA059FC4}" type="datetimeFigureOut">
               <a:rPr lang="en-US" smtClean="0"/>
-              <a:t>5/6/2026</a:t>
+              <a:t>5/7/2026</a:t>
             </a:fld>
             <a:endParaRPr lang="en-US"/>
           </a:p>
@@ -1100,7 +1100,7 @@
           <a:p>
             <a:fld id="{5BCAD085-E8A6-8845-BD4E-CB4CCA059FC4}" type="datetimeFigureOut">
               <a:rPr lang="en-US" smtClean="0"/>
-              <a:t>5/6/2026</a:t>
+              <a:t>5/7/2026</a:t>
             </a:fld>
             <a:endParaRPr lang="en-US"/>
           </a:p>
@@ -1385,7 +1385,7 @@
           <a:p>
             <a:fld id="{5BCAD085-E8A6-8845-BD4E-CB4CCA059FC4}" type="datetimeFigureOut">
               <a:rPr lang="en-US" smtClean="0"/>
-              <a:t>5/6/2026</a:t>
+              <a:t>5/7/2026</a:t>
             </a:fld>
             <a:endParaRPr lang="en-US"/>
           </a:p>
@@ -1804,7 +1804,7 @@
           <a:p>
             <a:fld id="{5BCAD085-E8A6-8845-BD4E-CB4CCA059FC4}" type="datetimeFigureOut">
               <a:rPr lang="en-US" smtClean="0"/>
-              <a:t>5/6/2026</a:t>
+              <a:t>5/7/2026</a:t>
             </a:fld>
             <a:endParaRPr lang="en-US"/>
           </a:p>
@@ -1921,7 +1921,7 @@
           <a:p>
             <a:fld id="{5BCAD085-E8A6-8845-BD4E-CB4CCA059FC4}" type="datetimeFigureOut">
               <a:rPr lang="en-US" smtClean="0"/>
-              <a:t>5/6/2026</a:t>
+              <a:t>5/7/2026</a:t>
             </a:fld>
             <a:endParaRPr lang="en-US"/>
           </a:p>
@@ -2016,7 +2016,7 @@
           <a:p>
             <a:fld id="{5BCAD085-E8A6-8845-BD4E-CB4CCA059FC4}" type="datetimeFigureOut">
               <a:rPr lang="en-US" smtClean="0"/>
-              <a:t>5/6/2026</a:t>
+              <a:t>5/7/2026</a:t>
             </a:fld>
             <a:endParaRPr lang="en-US"/>
           </a:p>
@@ -2291,7 +2291,7 @@
           <a:p>
             <a:fld id="{5BCAD085-E8A6-8845-BD4E-CB4CCA059FC4}" type="datetimeFigureOut">
               <a:rPr lang="en-US" smtClean="0"/>
-              <a:t>5/6/2026</a:t>
+              <a:t>5/7/2026</a:t>
             </a:fld>
             <a:endParaRPr lang="en-US"/>
           </a:p>
@@ -2543,7 +2543,7 @@
           <a:p>
             <a:fld id="{5BCAD085-E8A6-8845-BD4E-CB4CCA059FC4}" type="datetimeFigureOut">
               <a:rPr lang="en-US" smtClean="0"/>
-              <a:t>5/6/2026</a:t>
+              <a:t>5/7/2026</a:t>
             </a:fld>
             <a:endParaRPr lang="en-US"/>
           </a:p>
@@ -2754,7 +2754,7 @@
           <a:p>
             <a:fld id="{5BCAD085-E8A6-8845-BD4E-CB4CCA059FC4}" type="datetimeFigureOut">
               <a:rPr lang="en-US" smtClean="0"/>
-              <a:t>5/6/2026</a:t>
+              <a:t>5/7/2026</a:t>
             </a:fld>
             <a:endParaRPr lang="en-US"/>
           </a:p>
@@ -3476,6 +3476,18 @@
   <p:clrMapOvr>
     <a:masterClrMapping/>
   </p:clrMapOvr>
+  <mc:AlternateContent xmlns:mc="http://schemas.openxmlformats.org/markup-compatibility/2006">
+    <mc:Choice xmlns:p14="http://schemas.microsoft.com/office/powerpoint/2010/main" Requires="p14">
+      <p:transition spd="slow" p14:dur="2000">
+        <p:cut/>
+      </p:transition>
+    </mc:Choice>
+    <mc:Fallback>
+      <p:transition spd="slow">
+        <p:cut/>
+      </p:transition>
+    </mc:Fallback>
+  </mc:AlternateContent>
 </p:sld>
 </file>
 
@@ -4027,6 +4039,18 @@
   <p:clrMapOvr>
     <a:masterClrMapping/>
   </p:clrMapOvr>
+  <mc:AlternateContent xmlns:mc="http://schemas.openxmlformats.org/markup-compatibility/2006">
+    <mc:Choice xmlns:p14="http://schemas.microsoft.com/office/powerpoint/2010/main" Requires="p14">
+      <p:transition spd="slow" p14:dur="2000">
+        <p:cut/>
+      </p:transition>
+    </mc:Choice>
+    <mc:Fallback>
+      <p:transition spd="slow">
+        <p:cut/>
+      </p:transition>
+    </mc:Fallback>
+  </mc:AlternateContent>
 </p:sld>
 </file>
 
@@ -5017,6 +5041,18 @@
   <p:clrMapOvr>
     <a:masterClrMapping/>
   </p:clrMapOvr>
+  <mc:AlternateContent xmlns:mc="http://schemas.openxmlformats.org/markup-compatibility/2006">
+    <mc:Choice xmlns:p14="http://schemas.microsoft.com/office/powerpoint/2010/main" Requires="p14">
+      <p:transition spd="slow" p14:dur="2000">
+        <p:cut/>
+      </p:transition>
+    </mc:Choice>
+    <mc:Fallback>
+      <p:transition spd="slow">
+        <p:cut/>
+      </p:transition>
+    </mc:Fallback>
+  </mc:AlternateContent>
 </p:sld>
 </file>
 
@@ -5551,6 +5587,18 @@
   <p:clrMapOvr>
     <a:masterClrMapping/>
   </p:clrMapOvr>
+  <mc:AlternateContent xmlns:mc="http://schemas.openxmlformats.org/markup-compatibility/2006">
+    <mc:Choice xmlns:p14="http://schemas.microsoft.com/office/powerpoint/2010/main" Requires="p14">
+      <p:transition spd="slow" p14:dur="2000">
+        <p:cut/>
+      </p:transition>
+    </mc:Choice>
+    <mc:Fallback>
+      <p:transition spd="slow">
+        <p:cut/>
+      </p:transition>
+    </mc:Fallback>
+  </mc:AlternateContent>
 </p:sld>
 </file>
 
@@ -5760,6 +5808,18 @@
   <p:clrMapOvr>
     <a:masterClrMapping/>
   </p:clrMapOvr>
+  <mc:AlternateContent xmlns:mc="http://schemas.openxmlformats.org/markup-compatibility/2006">
+    <mc:Choice xmlns:p14="http://schemas.microsoft.com/office/powerpoint/2010/main" Requires="p14">
+      <p:transition spd="slow" p14:dur="2000">
+        <p:cut/>
+      </p:transition>
+    </mc:Choice>
+    <mc:Fallback>
+      <p:transition spd="slow">
+        <p:cut/>
+      </p:transition>
+    </mc:Fallback>
+  </mc:AlternateContent>
 </p:sld>
 </file>
 
@@ -6647,6 +6707,18 @@
   <p:clrMapOvr>
     <a:masterClrMapping/>
   </p:clrMapOvr>
+  <mc:AlternateContent xmlns:mc="http://schemas.openxmlformats.org/markup-compatibility/2006">
+    <mc:Choice xmlns:p14="http://schemas.microsoft.com/office/powerpoint/2010/main" Requires="p14">
+      <p:transition spd="slow" p14:dur="2000">
+        <p:cut/>
+      </p:transition>
+    </mc:Choice>
+    <mc:Fallback>
+      <p:transition spd="slow">
+        <p:cut/>
+      </p:transition>
+    </mc:Fallback>
+  </mc:AlternateContent>
 </p:sld>
 </file>
 
@@ -7860,6 +7932,18 @@
   <p:clrMapOvr>
     <a:masterClrMapping/>
   </p:clrMapOvr>
+  <mc:AlternateContent xmlns:mc="http://schemas.openxmlformats.org/markup-compatibility/2006">
+    <mc:Choice xmlns:p14="http://schemas.microsoft.com/office/powerpoint/2010/main" Requires="p14">
+      <p:transition spd="slow" p14:dur="2000">
+        <p:cut/>
+      </p:transition>
+    </mc:Choice>
+    <mc:Fallback>
+      <p:transition spd="slow">
+        <p:cut/>
+      </p:transition>
+    </mc:Fallback>
+  </mc:AlternateContent>
 </p:sld>
 </file>
 
@@ -8590,6 +8674,18 @@
   <p:clrMapOvr>
     <a:masterClrMapping/>
   </p:clrMapOvr>
+  <mc:AlternateContent xmlns:mc="http://schemas.openxmlformats.org/markup-compatibility/2006">
+    <mc:Choice xmlns:p14="http://schemas.microsoft.com/office/powerpoint/2010/main" Requires="p14">
+      <p:transition spd="slow" p14:dur="2000">
+        <p:cut/>
+      </p:transition>
+    </mc:Choice>
+    <mc:Fallback>
+      <p:transition spd="slow">
+        <p:cut/>
+      </p:transition>
+    </mc:Fallback>
+  </mc:AlternateContent>
 </p:sld>
 </file>
 
@@ -8799,6 +8895,18 @@
   <p:clrMapOvr>
     <a:masterClrMapping/>
   </p:clrMapOvr>
+  <mc:AlternateContent xmlns:mc="http://schemas.openxmlformats.org/markup-compatibility/2006">
+    <mc:Choice xmlns:p14="http://schemas.microsoft.com/office/powerpoint/2010/main" Requires="p14">
+      <p:transition spd="slow" p14:dur="2000">
+        <p:cut/>
+      </p:transition>
+    </mc:Choice>
+    <mc:Fallback>
+      <p:transition spd="slow">
+        <p:cut/>
+      </p:transition>
+    </mc:Fallback>
+  </mc:AlternateContent>
 </p:sld>
 </file>
 
@@ -9754,6 +9862,18 @@
   <p:clrMapOvr>
     <a:masterClrMapping/>
   </p:clrMapOvr>
+  <mc:AlternateContent xmlns:mc="http://schemas.openxmlformats.org/markup-compatibility/2006">
+    <mc:Choice xmlns:p14="http://schemas.microsoft.com/office/powerpoint/2010/main" Requires="p14">
+      <p:transition spd="slow" p14:dur="2000">
+        <p:cut/>
+      </p:transition>
+    </mc:Choice>
+    <mc:Fallback>
+      <p:transition spd="slow">
+        <p:cut/>
+      </p:transition>
+    </mc:Fallback>
+  </mc:AlternateContent>
 </p:sld>
 </file>
 
@@ -9979,14 +10099,47 @@
               </a:lnSpc>
             </a:pPr>
             <a:r>
-              <a:rPr sz="1400">
+              <a:rPr sz="1400" dirty="0">
                 <a:solidFill>
                   <a:srgbClr val="8B9DB8"/>
                 </a:solidFill>
                 <a:latin typeface="Consolas"/>
               </a:rPr>
-              <a:t># 1. Selectbox — 選一個認知測驗</a:t>
-            </a:r>
+              <a:t># 1. </a:t>
+            </a:r>
+            <a:r>
+              <a:rPr sz="1400" dirty="0" err="1">
+                <a:solidFill>
+                  <a:srgbClr val="8B9DB8"/>
+                </a:solidFill>
+                <a:latin typeface="Consolas"/>
+              </a:rPr>
+              <a:t>Selectbox</a:t>
+            </a:r>
+            <a:r>
+              <a:rPr sz="1400" dirty="0">
+                <a:solidFill>
+                  <a:srgbClr val="8B9DB8"/>
+                </a:solidFill>
+                <a:latin typeface="Consolas"/>
+              </a:rPr>
+              <a:t> — </a:t>
+            </a:r>
+            <a:r>
+              <a:rPr sz="1400" dirty="0" err="1">
+                <a:solidFill>
+                  <a:srgbClr val="8B9DB8"/>
+                </a:solidFill>
+                <a:latin typeface="Consolas"/>
+              </a:rPr>
+              <a:t>選一個認知測驗</a:t>
+            </a:r>
+            <a:endParaRPr sz="1400" dirty="0">
+              <a:solidFill>
+                <a:srgbClr val="8B9DB8"/>
+              </a:solidFill>
+              <a:latin typeface="Consolas"/>
+            </a:endParaRPr>
           </a:p>
           <a:p>
             <a:pPr algn="l">
@@ -9995,13 +10148,31 @@
               </a:lnSpc>
             </a:pPr>
             <a:r>
-              <a:rPr sz="1400">
+              <a:rPr sz="1400" dirty="0">
                 <a:solidFill>
                   <a:srgbClr val="FFFFFF"/>
                 </a:solidFill>
                 <a:latin typeface="Consolas"/>
               </a:rPr>
-              <a:t>measure = st.selectbox("Cognitive measure",</a:t>
+              <a:t>measure = </a:t>
+            </a:r>
+            <a:r>
+              <a:rPr sz="1400" dirty="0" err="1">
+                <a:solidFill>
+                  <a:srgbClr val="FFFFFF"/>
+                </a:solidFill>
+                <a:latin typeface="Consolas"/>
+              </a:rPr>
+              <a:t>st.selectbox</a:t>
+            </a:r>
+            <a:r>
+              <a:rPr sz="1400" dirty="0">
+                <a:solidFill>
+                  <a:srgbClr val="FFFFFF"/>
+                </a:solidFill>
+                <a:latin typeface="Consolas"/>
+              </a:rPr>
+              <a:t>("Cognitive measure",</a:t>
             </a:r>
           </a:p>
           <a:p>
@@ -10011,13 +10182,67 @@
               </a:lnSpc>
             </a:pPr>
             <a:r>
-              <a:rPr sz="1400">
+              <a:rPr sz="1400" dirty="0">
                 <a:solidFill>
                   <a:srgbClr val="FFFFFF"/>
                 </a:solidFill>
                 <a:latin typeface="Consolas"/>
               </a:rPr>
-              <a:t>    options=["reaction_time_ms", "moca_score", "working_memory_span"])</a:t>
+              <a:t>    options=["</a:t>
+            </a:r>
+            <a:r>
+              <a:rPr sz="1400" dirty="0" err="1">
+                <a:solidFill>
+                  <a:srgbClr val="FFFFFF"/>
+                </a:solidFill>
+                <a:latin typeface="Consolas"/>
+              </a:rPr>
+              <a:t>reaction_time_ms</a:t>
+            </a:r>
+            <a:r>
+              <a:rPr sz="1400" dirty="0">
+                <a:solidFill>
+                  <a:srgbClr val="FFFFFF"/>
+                </a:solidFill>
+                <a:latin typeface="Consolas"/>
+              </a:rPr>
+              <a:t>", "</a:t>
+            </a:r>
+            <a:r>
+              <a:rPr sz="1400" dirty="0" err="1">
+                <a:solidFill>
+                  <a:srgbClr val="FFFFFF"/>
+                </a:solidFill>
+                <a:latin typeface="Consolas"/>
+              </a:rPr>
+              <a:t>moca_score</a:t>
+            </a:r>
+            <a:r>
+              <a:rPr sz="1400" dirty="0">
+                <a:solidFill>
+                  <a:srgbClr val="FFFFFF"/>
+                </a:solidFill>
+                <a:latin typeface="Consolas"/>
+              </a:rPr>
+              <a:t>", "</a:t>
+            </a:r>
+            <a:r>
+              <a:rPr sz="1400" dirty="0" err="1">
+                <a:solidFill>
+                  <a:srgbClr val="FFFFFF"/>
+                </a:solidFill>
+                <a:latin typeface="Consolas"/>
+              </a:rPr>
+              <a:t>working_memory_span</a:t>
+            </a:r>
+            <a:r>
+              <a:rPr sz="1400" dirty="0">
+                <a:solidFill>
+                  <a:srgbClr val="FFFFFF"/>
+                </a:solidFill>
+                <a:latin typeface="Consolas"/>
+              </a:rPr>
+              <a:t>"])</a:t>
             </a:r>
           </a:p>
           <a:p>
@@ -10027,7 +10252,7 @@
               </a:lnSpc>
             </a:pPr>
             <a:r>
-              <a:rPr sz="1400">
+              <a:rPr sz="1400" dirty="0">
                 <a:solidFill>
                   <a:srgbClr val="FFFFFF"/>
                 </a:solidFill>
@@ -10043,14 +10268,29 @@
               </a:lnSpc>
             </a:pPr>
             <a:r>
-              <a:rPr sz="1400">
+              <a:rPr sz="1400" dirty="0">
                 <a:solidFill>
                   <a:srgbClr val="8B9DB8"/>
                 </a:solidFill>
                 <a:latin typeface="Consolas"/>
               </a:rPr>
-              <a:t># 2. Range slider — 年齡範圍</a:t>
-            </a:r>
+              <a:t># 2. Range slider — </a:t>
+            </a:r>
+            <a:r>
+              <a:rPr sz="1400" dirty="0" err="1">
+                <a:solidFill>
+                  <a:srgbClr val="8B9DB8"/>
+                </a:solidFill>
+                <a:latin typeface="Consolas"/>
+              </a:rPr>
+              <a:t>年齡範圍</a:t>
+            </a:r>
+            <a:endParaRPr sz="1400" dirty="0">
+              <a:solidFill>
+                <a:srgbClr val="8B9DB8"/>
+              </a:solidFill>
+              <a:latin typeface="Consolas"/>
+            </a:endParaRPr>
           </a:p>
           <a:p>
             <a:pPr algn="l">
@@ -10059,13 +10299,58 @@
               </a:lnSpc>
             </a:pPr>
             <a:r>
-              <a:rPr sz="1400">
+              <a:rPr sz="1400" dirty="0" err="1">
                 <a:solidFill>
                   <a:srgbClr val="FFFFFF"/>
                 </a:solidFill>
                 <a:latin typeface="Consolas"/>
               </a:rPr>
-              <a:t>age_min, age_max = st.slider("Age range", 20, 80, (20, 80))</a:t>
+              <a:t>age_min</a:t>
+            </a:r>
+            <a:r>
+              <a:rPr sz="1400" dirty="0">
+                <a:solidFill>
+                  <a:srgbClr val="FFFFFF"/>
+                </a:solidFill>
+                <a:latin typeface="Consolas"/>
+              </a:rPr>
+              <a:t>, </a:t>
+            </a:r>
+            <a:r>
+              <a:rPr sz="1400" dirty="0" err="1">
+                <a:solidFill>
+                  <a:srgbClr val="FFFFFF"/>
+                </a:solidFill>
+                <a:latin typeface="Consolas"/>
+              </a:rPr>
+              <a:t>age_max</a:t>
+            </a:r>
+            <a:r>
+              <a:rPr sz="1400" dirty="0">
+                <a:solidFill>
+                  <a:srgbClr val="FFFFFF"/>
+                </a:solidFill>
+                <a:latin typeface="Consolas"/>
+              </a:rPr>
+              <a:t> = </a:t>
+            </a:r>
+            <a:r>
+              <a:rPr sz="1400" dirty="0" err="1">
+                <a:solidFill>
+                  <a:srgbClr val="FFFFFF"/>
+                </a:solidFill>
+                <a:latin typeface="Consolas"/>
+              </a:rPr>
+              <a:t>st.slider</a:t>
+            </a:r>
+            <a:r>
+              <a:rPr sz="1400" dirty="0">
+                <a:solidFill>
+                  <a:srgbClr val="FFFFFF"/>
+                </a:solidFill>
+                <a:latin typeface="Consolas"/>
+              </a:rPr>
+              <a:t>("Age range", 20, 80, (20, 80))</a:t>
             </a:r>
           </a:p>
           <a:p>
@@ -10075,7 +10360,7 @@
               </a:lnSpc>
             </a:pPr>
             <a:r>
-              <a:rPr sz="1400">
+              <a:rPr sz="1400" dirty="0">
                 <a:solidFill>
                   <a:srgbClr val="FFFFFF"/>
                 </a:solidFill>
@@ -10091,14 +10376,29 @@
               </a:lnSpc>
             </a:pPr>
             <a:r>
-              <a:rPr sz="1400">
+              <a:rPr sz="1400" dirty="0">
                 <a:solidFill>
                   <a:srgbClr val="8B9DB8"/>
                 </a:solidFill>
                 <a:latin typeface="Consolas"/>
               </a:rPr>
-              <a:t># 3. Multiselect — 性別</a:t>
-            </a:r>
+              <a:t># 3. Multiselect — </a:t>
+            </a:r>
+            <a:r>
+              <a:rPr sz="1400" dirty="0" err="1">
+                <a:solidFill>
+                  <a:srgbClr val="8B9DB8"/>
+                </a:solidFill>
+                <a:latin typeface="Consolas"/>
+              </a:rPr>
+              <a:t>性別</a:t>
+            </a:r>
+            <a:endParaRPr sz="1400" dirty="0">
+              <a:solidFill>
+                <a:srgbClr val="8B9DB8"/>
+              </a:solidFill>
+              <a:latin typeface="Consolas"/>
+            </a:endParaRPr>
           </a:p>
           <a:p>
             <a:pPr algn="l">
@@ -10107,13 +10407,40 @@
               </a:lnSpc>
             </a:pPr>
             <a:r>
-              <a:rPr sz="1400">
+              <a:rPr sz="1400" dirty="0" err="1">
                 <a:solidFill>
                   <a:srgbClr val="FFFFFF"/>
                 </a:solidFill>
                 <a:latin typeface="Consolas"/>
               </a:rPr>
-              <a:t>sex_choices = st.multiselect("Sex", options=["F", "M"], default=["F", "M"])</a:t>
+              <a:t>sex_choices</a:t>
+            </a:r>
+            <a:r>
+              <a:rPr sz="1400" dirty="0">
+                <a:solidFill>
+                  <a:srgbClr val="FFFFFF"/>
+                </a:solidFill>
+                <a:latin typeface="Consolas"/>
+              </a:rPr>
+              <a:t> = </a:t>
+            </a:r>
+            <a:r>
+              <a:rPr sz="1400" dirty="0" err="1">
+                <a:solidFill>
+                  <a:srgbClr val="FFFFFF"/>
+                </a:solidFill>
+                <a:latin typeface="Consolas"/>
+              </a:rPr>
+              <a:t>st.multiselect</a:t>
+            </a:r>
+            <a:r>
+              <a:rPr sz="1400" dirty="0">
+                <a:solidFill>
+                  <a:srgbClr val="FFFFFF"/>
+                </a:solidFill>
+                <a:latin typeface="Consolas"/>
+              </a:rPr>
+              <a:t>("Sex", options=["F", "M"], default=["F", "M"])</a:t>
             </a:r>
           </a:p>
           <a:p>
@@ -10123,7 +10450,7 @@
               </a:lnSpc>
             </a:pPr>
             <a:r>
-              <a:rPr sz="1400">
+              <a:rPr sz="1400" dirty="0">
                 <a:solidFill>
                   <a:srgbClr val="FFFFFF"/>
                 </a:solidFill>
@@ -10139,14 +10466,47 @@
               </a:lnSpc>
             </a:pPr>
             <a:r>
-              <a:rPr sz="1400">
+              <a:rPr sz="1400" dirty="0">
                 <a:solidFill>
                   <a:srgbClr val="8B9DB8"/>
                 </a:solidFill>
                 <a:latin typeface="Consolas"/>
               </a:rPr>
-              <a:t># 4. 用 boolean mask 篩選</a:t>
-            </a:r>
+              <a:t># 4. 用 </a:t>
+            </a:r>
+            <a:r>
+              <a:rPr sz="1400" dirty="0" err="1">
+                <a:solidFill>
+                  <a:srgbClr val="8B9DB8"/>
+                </a:solidFill>
+                <a:latin typeface="Consolas"/>
+              </a:rPr>
+              <a:t>boolean</a:t>
+            </a:r>
+            <a:r>
+              <a:rPr sz="1400" dirty="0">
+                <a:solidFill>
+                  <a:srgbClr val="8B9DB8"/>
+                </a:solidFill>
+                <a:latin typeface="Consolas"/>
+              </a:rPr>
+              <a:t> mask </a:t>
+            </a:r>
+            <a:r>
+              <a:rPr sz="1400" dirty="0" err="1">
+                <a:solidFill>
+                  <a:srgbClr val="8B9DB8"/>
+                </a:solidFill>
+                <a:latin typeface="Consolas"/>
+              </a:rPr>
+              <a:t>篩選</a:t>
+            </a:r>
+            <a:endParaRPr sz="1400" dirty="0">
+              <a:solidFill>
+                <a:srgbClr val="8B9DB8"/>
+              </a:solidFill>
+              <a:latin typeface="Consolas"/>
+            </a:endParaRPr>
           </a:p>
           <a:p>
             <a:pPr algn="l">
@@ -10155,13 +10515,121 @@
               </a:lnSpc>
             </a:pPr>
             <a:r>
-              <a:rPr sz="1400">
+              <a:rPr sz="1400" dirty="0">
                 <a:solidFill>
                   <a:srgbClr val="FFFFFF"/>
                 </a:solidFill>
                 <a:latin typeface="Consolas"/>
               </a:rPr>
-              <a:t>mask = df["age"].between(age_min, age_max) &amp; df["sex"].isin(sex_choices)</a:t>
+              <a:t>mask = </a:t>
+            </a:r>
+            <a:r>
+              <a:rPr sz="1400" dirty="0" err="1">
+                <a:solidFill>
+                  <a:srgbClr val="FFFFFF"/>
+                </a:solidFill>
+                <a:latin typeface="Consolas"/>
+              </a:rPr>
+              <a:t>df</a:t>
+            </a:r>
+            <a:r>
+              <a:rPr sz="1400" dirty="0">
+                <a:solidFill>
+                  <a:srgbClr val="FFFFFF"/>
+                </a:solidFill>
+                <a:latin typeface="Consolas"/>
+              </a:rPr>
+              <a:t>["age"].between(</a:t>
+            </a:r>
+            <a:r>
+              <a:rPr sz="1400" dirty="0" err="1">
+                <a:solidFill>
+                  <a:srgbClr val="FFFFFF"/>
+                </a:solidFill>
+                <a:latin typeface="Consolas"/>
+              </a:rPr>
+              <a:t>age_min</a:t>
+            </a:r>
+            <a:r>
+              <a:rPr sz="1400" dirty="0">
+                <a:solidFill>
+                  <a:srgbClr val="FFFFFF"/>
+                </a:solidFill>
+                <a:latin typeface="Consolas"/>
+              </a:rPr>
+              <a:t>, </a:t>
+            </a:r>
+            <a:r>
+              <a:rPr sz="1400" dirty="0" err="1">
+                <a:solidFill>
+                  <a:srgbClr val="FFFFFF"/>
+                </a:solidFill>
+                <a:latin typeface="Consolas"/>
+              </a:rPr>
+              <a:t>age_max</a:t>
+            </a:r>
+            <a:r>
+              <a:rPr sz="1400" dirty="0">
+                <a:solidFill>
+                  <a:srgbClr val="FFFFFF"/>
+                </a:solidFill>
+                <a:latin typeface="Consolas"/>
+              </a:rPr>
+              <a:t>) &amp; </a:t>
+            </a:r>
+            <a:r>
+              <a:rPr sz="1400" dirty="0" err="1">
+                <a:solidFill>
+                  <a:srgbClr val="FFFFFF"/>
+                </a:solidFill>
+                <a:latin typeface="Consolas"/>
+              </a:rPr>
+              <a:t>df</a:t>
+            </a:r>
+            <a:r>
+              <a:rPr sz="1400" dirty="0">
+                <a:solidFill>
+                  <a:srgbClr val="FFFFFF"/>
+                </a:solidFill>
+                <a:latin typeface="Consolas"/>
+              </a:rPr>
+              <a:t>["sex"].</a:t>
+            </a:r>
+            <a:r>
+              <a:rPr sz="1400" dirty="0" err="1">
+                <a:solidFill>
+                  <a:srgbClr val="FFFFFF"/>
+                </a:solidFill>
+                <a:latin typeface="Consolas"/>
+              </a:rPr>
+              <a:t>isin</a:t>
+            </a:r>
+            <a:r>
+              <a:rPr sz="1400" dirty="0">
+                <a:solidFill>
+                  <a:srgbClr val="FFFFFF"/>
+                </a:solidFill>
+                <a:latin typeface="Consolas"/>
+              </a:rPr>
+              <a:t>(</a:t>
+            </a:r>
+            <a:r>
+              <a:rPr sz="1400" dirty="0" err="1">
+                <a:solidFill>
+                  <a:srgbClr val="FFFFFF"/>
+                </a:solidFill>
+                <a:latin typeface="Consolas"/>
+              </a:rPr>
+              <a:t>sex_choices</a:t>
+            </a:r>
+            <a:r>
+              <a:rPr sz="1400" dirty="0">
+                <a:solidFill>
+                  <a:srgbClr val="FFFFFF"/>
+                </a:solidFill>
+                <a:latin typeface="Consolas"/>
+              </a:rPr>
+              <a:t>)</a:t>
             </a:r>
           </a:p>
           <a:p>
@@ -10171,13 +10639,40 @@
               </a:lnSpc>
             </a:pPr>
             <a:r>
-              <a:rPr sz="1400">
+              <a:rPr sz="1400" dirty="0" err="1">
                 <a:solidFill>
                   <a:srgbClr val="FFFFFF"/>
                 </a:solidFill>
                 <a:latin typeface="Consolas"/>
               </a:rPr>
-              <a:t>df_filtered = df[mask]</a:t>
+              <a:t>df_filtered</a:t>
+            </a:r>
+            <a:r>
+              <a:rPr sz="1400" dirty="0">
+                <a:solidFill>
+                  <a:srgbClr val="FFFFFF"/>
+                </a:solidFill>
+                <a:latin typeface="Consolas"/>
+              </a:rPr>
+              <a:t> = </a:t>
+            </a:r>
+            <a:r>
+              <a:rPr sz="1400" dirty="0" err="1">
+                <a:solidFill>
+                  <a:srgbClr val="FFFFFF"/>
+                </a:solidFill>
+                <a:latin typeface="Consolas"/>
+              </a:rPr>
+              <a:t>df</a:t>
+            </a:r>
+            <a:r>
+              <a:rPr sz="1400" dirty="0">
+                <a:solidFill>
+                  <a:srgbClr val="FFFFFF"/>
+                </a:solidFill>
+                <a:latin typeface="Consolas"/>
+              </a:rPr>
+              <a:t>[mask]</a:t>
             </a:r>
           </a:p>
         </p:txBody>
@@ -10292,6 +10787,18 @@
   <p:clrMapOvr>
     <a:masterClrMapping/>
   </p:clrMapOvr>
+  <mc:AlternateContent xmlns:mc="http://schemas.openxmlformats.org/markup-compatibility/2006">
+    <mc:Choice xmlns:p14="http://schemas.microsoft.com/office/powerpoint/2010/main" Requires="p14">
+      <p:transition spd="slow" p14:dur="2000">
+        <p:cut/>
+      </p:transition>
+    </mc:Choice>
+    <mc:Fallback>
+      <p:transition spd="slow">
+        <p:cut/>
+      </p:transition>
+    </mc:Fallback>
+  </mc:AlternateContent>
 </p:sld>
 </file>
 
@@ -10761,6 +11268,18 @@
   <p:clrMapOvr>
     <a:masterClrMapping/>
   </p:clrMapOvr>
+  <mc:AlternateContent xmlns:mc="http://schemas.openxmlformats.org/markup-compatibility/2006">
+    <mc:Choice xmlns:p14="http://schemas.microsoft.com/office/powerpoint/2010/main" Requires="p14">
+      <p:transition spd="slow" p14:dur="2000">
+        <p:cut/>
+      </p:transition>
+    </mc:Choice>
+    <mc:Fallback>
+      <p:transition spd="slow">
+        <p:cut/>
+      </p:transition>
+    </mc:Fallback>
+  </mc:AlternateContent>
 </p:sld>
 </file>
 
@@ -11425,6 +11944,18 @@
   <p:clrMapOvr>
     <a:masterClrMapping/>
   </p:clrMapOvr>
+  <mc:AlternateContent xmlns:mc="http://schemas.openxmlformats.org/markup-compatibility/2006">
+    <mc:Choice xmlns:p14="http://schemas.microsoft.com/office/powerpoint/2010/main" Requires="p14">
+      <p:transition spd="slow" p14:dur="2000">
+        <p:cut/>
+      </p:transition>
+    </mc:Choice>
+    <mc:Fallback>
+      <p:transition spd="slow">
+        <p:cut/>
+      </p:transition>
+    </mc:Fallback>
+  </mc:AlternateContent>
 </p:sld>
 </file>
 
@@ -12069,6 +12600,18 @@
   <p:clrMapOvr>
     <a:masterClrMapping/>
   </p:clrMapOvr>
+  <mc:AlternateContent xmlns:mc="http://schemas.openxmlformats.org/markup-compatibility/2006">
+    <mc:Choice xmlns:p14="http://schemas.microsoft.com/office/powerpoint/2010/main" Requires="p14">
+      <p:transition spd="slow" p14:dur="2000">
+        <p:cut/>
+      </p:transition>
+    </mc:Choice>
+    <mc:Fallback>
+      <p:transition spd="slow">
+        <p:cut/>
+      </p:transition>
+    </mc:Fallback>
+  </mc:AlternateContent>
 </p:sld>
 </file>
 
@@ -12607,6 +13150,18 @@
   <p:clrMapOvr>
     <a:masterClrMapping/>
   </p:clrMapOvr>
+  <mc:AlternateContent xmlns:mc="http://schemas.openxmlformats.org/markup-compatibility/2006">
+    <mc:Choice xmlns:p14="http://schemas.microsoft.com/office/powerpoint/2010/main" Requires="p14">
+      <p:transition spd="slow" p14:dur="2000">
+        <p:cut/>
+      </p:transition>
+    </mc:Choice>
+    <mc:Fallback>
+      <p:transition spd="slow">
+        <p:cut/>
+      </p:transition>
+    </mc:Fallback>
+  </mc:AlternateContent>
 </p:sld>
 </file>
 
@@ -12816,6 +13371,18 @@
   <p:clrMapOvr>
     <a:masterClrMapping/>
   </p:clrMapOvr>
+  <mc:AlternateContent xmlns:mc="http://schemas.openxmlformats.org/markup-compatibility/2006">
+    <mc:Choice xmlns:p14="http://schemas.microsoft.com/office/powerpoint/2010/main" Requires="p14">
+      <p:transition spd="slow" p14:dur="2000">
+        <p:cut/>
+      </p:transition>
+    </mc:Choice>
+    <mc:Fallback>
+      <p:transition spd="slow">
+        <p:cut/>
+      </p:transition>
+    </mc:Fallback>
+  </mc:AlternateContent>
 </p:sld>
 </file>
 
@@ -13415,6 +13982,18 @@
   <p:clrMapOvr>
     <a:masterClrMapping/>
   </p:clrMapOvr>
+  <mc:AlternateContent xmlns:mc="http://schemas.openxmlformats.org/markup-compatibility/2006">
+    <mc:Choice xmlns:p14="http://schemas.microsoft.com/office/powerpoint/2010/main" Requires="p14">
+      <p:transition spd="slow" p14:dur="2000">
+        <p:cut/>
+      </p:transition>
+    </mc:Choice>
+    <mc:Fallback>
+      <p:transition spd="slow">
+        <p:cut/>
+      </p:transition>
+    </mc:Fallback>
+  </mc:AlternateContent>
 </p:sld>
 </file>
 
@@ -14001,6 +14580,18 @@
   <p:clrMapOvr>
     <a:masterClrMapping/>
   </p:clrMapOvr>
+  <mc:AlternateContent xmlns:mc="http://schemas.openxmlformats.org/markup-compatibility/2006">
+    <mc:Choice xmlns:p14="http://schemas.microsoft.com/office/powerpoint/2010/main" Requires="p14">
+      <p:transition spd="slow" p14:dur="2000">
+        <p:cut/>
+      </p:transition>
+    </mc:Choice>
+    <mc:Fallback>
+      <p:transition spd="slow">
+        <p:cut/>
+      </p:transition>
+    </mc:Fallback>
+  </mc:AlternateContent>
 </p:sld>
 </file>
 
@@ -14210,6 +14801,18 @@
   <p:clrMapOvr>
     <a:masterClrMapping/>
   </p:clrMapOvr>
+  <mc:AlternateContent xmlns:mc="http://schemas.openxmlformats.org/markup-compatibility/2006">
+    <mc:Choice xmlns:p14="http://schemas.microsoft.com/office/powerpoint/2010/main" Requires="p14">
+      <p:transition spd="slow" p14:dur="2000">
+        <p:cut/>
+      </p:transition>
+    </mc:Choice>
+    <mc:Fallback>
+      <p:transition spd="slow">
+        <p:cut/>
+      </p:transition>
+    </mc:Fallback>
+  </mc:AlternateContent>
 </p:sld>
 </file>
 
@@ -15112,6 +15715,18 @@
   <p:clrMapOvr>
     <a:masterClrMapping/>
   </p:clrMapOvr>
+  <mc:AlternateContent xmlns:mc="http://schemas.openxmlformats.org/markup-compatibility/2006">
+    <mc:Choice xmlns:p14="http://schemas.microsoft.com/office/powerpoint/2010/main" Requires="p14">
+      <p:transition spd="slow" p14:dur="2000">
+        <p:cut/>
+      </p:transition>
+    </mc:Choice>
+    <mc:Fallback>
+      <p:transition spd="slow">
+        <p:cut/>
+      </p:transition>
+    </mc:Fallback>
+  </mc:AlternateContent>
 </p:sld>
 </file>
 
@@ -15732,6 +16347,18 @@
   <p:clrMapOvr>
     <a:masterClrMapping/>
   </p:clrMapOvr>
+  <mc:AlternateContent xmlns:mc="http://schemas.openxmlformats.org/markup-compatibility/2006">
+    <mc:Choice xmlns:p14="http://schemas.microsoft.com/office/powerpoint/2010/main" Requires="p14">
+      <p:transition spd="slow" p14:dur="2000">
+        <p:cut/>
+      </p:transition>
+    </mc:Choice>
+    <mc:Fallback>
+      <p:transition spd="slow">
+        <p:cut/>
+      </p:transition>
+    </mc:Fallback>
+  </mc:AlternateContent>
 </p:sld>
 </file>
 
@@ -16270,6 +16897,18 @@
   <p:clrMapOvr>
     <a:masterClrMapping/>
   </p:clrMapOvr>
+  <mc:AlternateContent xmlns:mc="http://schemas.openxmlformats.org/markup-compatibility/2006">
+    <mc:Choice xmlns:p14="http://schemas.microsoft.com/office/powerpoint/2010/main" Requires="p14">
+      <p:transition spd="slow" p14:dur="2000">
+        <p:cut/>
+      </p:transition>
+    </mc:Choice>
+    <mc:Fallback>
+      <p:transition spd="slow">
+        <p:cut/>
+      </p:transition>
+    </mc:Fallback>
+  </mc:AlternateContent>
 </p:sld>
 </file>
 
@@ -16479,6 +17118,18 @@
   <p:clrMapOvr>
     <a:masterClrMapping/>
   </p:clrMapOvr>
+  <mc:AlternateContent xmlns:mc="http://schemas.openxmlformats.org/markup-compatibility/2006">
+    <mc:Choice xmlns:p14="http://schemas.microsoft.com/office/powerpoint/2010/main" Requires="p14">
+      <p:transition spd="slow" p14:dur="2000">
+        <p:cut/>
+      </p:transition>
+    </mc:Choice>
+    <mc:Fallback>
+      <p:transition spd="slow">
+        <p:cut/>
+      </p:transition>
+    </mc:Fallback>
+  </mc:AlternateContent>
 </p:sld>
 </file>
 
@@ -16688,6 +17339,18 @@
   <p:clrMapOvr>
     <a:masterClrMapping/>
   </p:clrMapOvr>
+  <mc:AlternateContent xmlns:mc="http://schemas.openxmlformats.org/markup-compatibility/2006">
+    <mc:Choice xmlns:p14="http://schemas.microsoft.com/office/powerpoint/2010/main" Requires="p14">
+      <p:transition spd="slow" p14:dur="2000">
+        <p:cut/>
+      </p:transition>
+    </mc:Choice>
+    <mc:Fallback>
+      <p:transition spd="slow">
+        <p:cut/>
+      </p:transition>
+    </mc:Fallback>
+  </mc:AlternateContent>
 </p:sld>
 </file>
 
@@ -17365,6 +18028,18 @@
   <p:clrMapOvr>
     <a:masterClrMapping/>
   </p:clrMapOvr>
+  <mc:AlternateContent xmlns:mc="http://schemas.openxmlformats.org/markup-compatibility/2006">
+    <mc:Choice xmlns:p14="http://schemas.microsoft.com/office/powerpoint/2010/main" Requires="p14">
+      <p:transition spd="slow" p14:dur="2000">
+        <p:cut/>
+      </p:transition>
+    </mc:Choice>
+    <mc:Fallback>
+      <p:transition spd="slow">
+        <p:cut/>
+      </p:transition>
+    </mc:Fallback>
+  </mc:AlternateContent>
 </p:sld>
 </file>
 
@@ -17551,8 +18226,8 @@
         </p:nvSpPr>
         <p:spPr>
           <a:xfrm>
-            <a:off x="640080" y="1828800"/>
-            <a:ext cx="10881360" cy="2560320"/>
+            <a:off x="655167" y="1479087"/>
+            <a:ext cx="10881360" cy="3245224"/>
           </a:xfrm>
           <a:prstGeom prst="roundRect">
             <a:avLst>
@@ -17590,7 +18265,7 @@
               </a:lnSpc>
             </a:pPr>
             <a:r>
-              <a:rPr sz="1600">
+              <a:rPr sz="1600" dirty="0">
                 <a:solidFill>
                   <a:srgbClr val="FFFFFF"/>
                 </a:solidFill>
@@ -17606,13 +18281,49 @@
               </a:lnSpc>
             </a:pPr>
             <a:r>
-              <a:rPr sz="1600">
+              <a:rPr sz="1600" dirty="0">
                 <a:solidFill>
                   <a:srgbClr val="FFFFFF"/>
                 </a:solidFill>
                 <a:latin typeface="Consolas"/>
               </a:rPr>
-              <a:t>def load_data(path: str) -&gt; pd.DataFrame:</a:t>
+              <a:t>def </a:t>
+            </a:r>
+            <a:r>
+              <a:rPr sz="1600" dirty="0" err="1">
+                <a:solidFill>
+                  <a:srgbClr val="FFFFFF"/>
+                </a:solidFill>
+                <a:latin typeface="Consolas"/>
+              </a:rPr>
+              <a:t>load_data</a:t>
+            </a:r>
+            <a:r>
+              <a:rPr sz="1600" dirty="0">
+                <a:solidFill>
+                  <a:srgbClr val="FFFFFF"/>
+                </a:solidFill>
+                <a:latin typeface="Consolas"/>
+              </a:rPr>
+              <a:t>(path: str) -&gt; </a:t>
+            </a:r>
+            <a:r>
+              <a:rPr sz="1600" dirty="0" err="1">
+                <a:solidFill>
+                  <a:srgbClr val="FFFFFF"/>
+                </a:solidFill>
+                <a:latin typeface="Consolas"/>
+              </a:rPr>
+              <a:t>pd.DataFrame</a:t>
+            </a:r>
+            <a:r>
+              <a:rPr sz="1600" dirty="0">
+                <a:solidFill>
+                  <a:srgbClr val="FFFFFF"/>
+                </a:solidFill>
+                <a:latin typeface="Consolas"/>
+              </a:rPr>
+              <a:t>:</a:t>
             </a:r>
           </a:p>
           <a:p>
@@ -17622,13 +18333,49 @@
               </a:lnSpc>
             </a:pPr>
             <a:r>
-              <a:rPr sz="1600">
+              <a:rPr sz="1600" dirty="0">
                 <a:solidFill>
                   <a:srgbClr val="FFFFFF"/>
                 </a:solidFill>
                 <a:latin typeface="Consolas"/>
               </a:rPr>
-              <a:t>    df = pd.read_csv(path)</a:t>
+              <a:t>    </a:t>
+            </a:r>
+            <a:r>
+              <a:rPr sz="1600" dirty="0" err="1">
+                <a:solidFill>
+                  <a:srgbClr val="FFFFFF"/>
+                </a:solidFill>
+                <a:latin typeface="Consolas"/>
+              </a:rPr>
+              <a:t>df</a:t>
+            </a:r>
+            <a:r>
+              <a:rPr sz="1600" dirty="0">
+                <a:solidFill>
+                  <a:srgbClr val="FFFFFF"/>
+                </a:solidFill>
+                <a:latin typeface="Consolas"/>
+              </a:rPr>
+              <a:t> = </a:t>
+            </a:r>
+            <a:r>
+              <a:rPr sz="1600" dirty="0" err="1">
+                <a:solidFill>
+                  <a:srgbClr val="FFFFFF"/>
+                </a:solidFill>
+                <a:latin typeface="Consolas"/>
+              </a:rPr>
+              <a:t>pd.read_csv</a:t>
+            </a:r>
+            <a:r>
+              <a:rPr sz="1600" dirty="0">
+                <a:solidFill>
+                  <a:srgbClr val="FFFFFF"/>
+                </a:solidFill>
+                <a:latin typeface="Consolas"/>
+              </a:rPr>
+              <a:t>(path)</a:t>
             </a:r>
           </a:p>
           <a:p>
@@ -17638,13 +18385,49 @@
               </a:lnSpc>
             </a:pPr>
             <a:r>
-              <a:rPr sz="1600">
+              <a:rPr sz="1600" dirty="0">
                 <a:solidFill>
                   <a:srgbClr val="FFFFFF"/>
                 </a:solidFill>
                 <a:latin typeface="Consolas"/>
               </a:rPr>
-              <a:t>    df["group"] = pd.Categorical(</a:t>
+              <a:t>    </a:t>
+            </a:r>
+            <a:r>
+              <a:rPr sz="1600" dirty="0" err="1">
+                <a:solidFill>
+                  <a:srgbClr val="FFFFFF"/>
+                </a:solidFill>
+                <a:latin typeface="Consolas"/>
+              </a:rPr>
+              <a:t>df</a:t>
+            </a:r>
+            <a:r>
+              <a:rPr sz="1600" dirty="0">
+                <a:solidFill>
+                  <a:srgbClr val="FFFFFF"/>
+                </a:solidFill>
+                <a:latin typeface="Consolas"/>
+              </a:rPr>
+              <a:t>["group"] = </a:t>
+            </a:r>
+            <a:r>
+              <a:rPr sz="1600" dirty="0" err="1">
+                <a:solidFill>
+                  <a:srgbClr val="FFFFFF"/>
+                </a:solidFill>
+                <a:latin typeface="Consolas"/>
+              </a:rPr>
+              <a:t>pd.Categorical</a:t>
+            </a:r>
+            <a:r>
+              <a:rPr sz="1600" dirty="0">
+                <a:solidFill>
+                  <a:srgbClr val="FFFFFF"/>
+                </a:solidFill>
+                <a:latin typeface="Consolas"/>
+              </a:rPr>
+              <a:t>(</a:t>
             </a:r>
           </a:p>
           <a:p>
@@ -17654,13 +18437,31 @@
               </a:lnSpc>
             </a:pPr>
             <a:r>
-              <a:rPr sz="1600">
+              <a:rPr sz="1600" dirty="0">
                 <a:solidFill>
                   <a:srgbClr val="FFFFFF"/>
                 </a:solidFill>
                 <a:latin typeface="Consolas"/>
               </a:rPr>
-              <a:t>        df["group"],</a:t>
+              <a:t>        </a:t>
+            </a:r>
+            <a:r>
+              <a:rPr sz="1600" dirty="0" err="1">
+                <a:solidFill>
+                  <a:srgbClr val="FFFFFF"/>
+                </a:solidFill>
+                <a:latin typeface="Consolas"/>
+              </a:rPr>
+              <a:t>df</a:t>
+            </a:r>
+            <a:r>
+              <a:rPr sz="1600" dirty="0">
+                <a:solidFill>
+                  <a:srgbClr val="FFFFFF"/>
+                </a:solidFill>
+                <a:latin typeface="Consolas"/>
+              </a:rPr>
+              <a:t>["group"],</a:t>
             </a:r>
           </a:p>
           <a:p>
@@ -17670,7 +18471,7 @@
               </a:lnSpc>
             </a:pPr>
             <a:r>
-              <a:rPr sz="1600">
+              <a:rPr sz="1600" dirty="0">
                 <a:solidFill>
                   <a:srgbClr val="FFFFFF"/>
                 </a:solidFill>
@@ -17686,7 +18487,7 @@
               </a:lnSpc>
             </a:pPr>
             <a:r>
-              <a:rPr sz="1600">
+              <a:rPr sz="1600" dirty="0">
                 <a:solidFill>
                   <a:srgbClr val="FFFFFF"/>
                 </a:solidFill>
@@ -17702,7 +18503,7 @@
               </a:lnSpc>
             </a:pPr>
             <a:r>
-              <a:rPr sz="1600">
+              <a:rPr sz="1600" dirty="0">
                 <a:solidFill>
                   <a:srgbClr val="FFFFFF"/>
                 </a:solidFill>
@@ -17718,14 +18519,29 @@
               </a:lnSpc>
             </a:pPr>
             <a:r>
-              <a:rPr sz="1600">
+              <a:rPr sz="1600" dirty="0">
                 <a:solidFill>
                   <a:srgbClr val="FFFFFF"/>
                 </a:solidFill>
                 <a:latin typeface="Consolas"/>
               </a:rPr>
-              <a:t>    return df</a:t>
-            </a:r>
+              <a:t>    return </a:t>
+            </a:r>
+            <a:r>
+              <a:rPr sz="1600" dirty="0" err="1">
+                <a:solidFill>
+                  <a:srgbClr val="FFFFFF"/>
+                </a:solidFill>
+                <a:latin typeface="Consolas"/>
+              </a:rPr>
+              <a:t>df</a:t>
+            </a:r>
+            <a:endParaRPr sz="1600" dirty="0">
+              <a:solidFill>
+                <a:srgbClr val="FFFFFF"/>
+              </a:solidFill>
+              <a:latin typeface="Consolas"/>
+            </a:endParaRPr>
           </a:p>
           <a:p>
             <a:pPr algn="l">
@@ -17734,7 +18550,7 @@
               </a:lnSpc>
             </a:pPr>
             <a:r>
-              <a:rPr sz="1600">
+              <a:rPr sz="1600" dirty="0">
                 <a:solidFill>
                   <a:srgbClr val="FFFFFF"/>
                 </a:solidFill>
@@ -17750,13 +18566,40 @@
               </a:lnSpc>
             </a:pPr>
             <a:r>
-              <a:rPr sz="1600">
+              <a:rPr sz="1600" dirty="0" err="1">
                 <a:solidFill>
                   <a:srgbClr val="FFFFFF"/>
                 </a:solidFill>
                 <a:latin typeface="Consolas"/>
               </a:rPr>
-              <a:t>df = load_data("data/cognitive_aging_taiwan.csv")</a:t>
+              <a:t>df</a:t>
+            </a:r>
+            <a:r>
+              <a:rPr sz="1600" dirty="0">
+                <a:solidFill>
+                  <a:srgbClr val="FFFFFF"/>
+                </a:solidFill>
+                <a:latin typeface="Consolas"/>
+              </a:rPr>
+              <a:t> = </a:t>
+            </a:r>
+            <a:r>
+              <a:rPr sz="1600" dirty="0" err="1">
+                <a:solidFill>
+                  <a:srgbClr val="FFFFFF"/>
+                </a:solidFill>
+                <a:latin typeface="Consolas"/>
+              </a:rPr>
+              <a:t>load_data</a:t>
+            </a:r>
+            <a:r>
+              <a:rPr sz="1600" dirty="0">
+                <a:solidFill>
+                  <a:srgbClr val="FFFFFF"/>
+                </a:solidFill>
+                <a:latin typeface="Consolas"/>
+              </a:rPr>
+              <a:t>("data/cognitive_aging_taiwan.csv")</a:t>
             </a:r>
           </a:p>
         </p:txBody>
@@ -17769,7 +18612,7 @@
         </p:nvSpPr>
         <p:spPr>
           <a:xfrm>
-            <a:off x="640080" y="4572000"/>
+            <a:off x="655167" y="4846320"/>
             <a:ext cx="10972800" cy="365760"/>
           </a:xfrm>
           <a:prstGeom prst="rect">
@@ -17785,13 +18628,22 @@
           <a:p>
             <a:pPr algn="l"/>
             <a:r>
-              <a:rPr sz="1800" b="1" i="0">
+              <a:rPr sz="1800" b="1" i="0" dirty="0" err="1">
                 <a:solidFill>
                   <a:srgbClr val="0D9B9B"/>
                 </a:solidFill>
                 <a:latin typeface="Microsoft JhengHei"/>
               </a:rPr>
-              <a:t>何時要 cache？</a:t>
+              <a:t>何時要</a:t>
+            </a:r>
+            <a:r>
+              <a:rPr sz="1800" b="1" i="0" dirty="0">
+                <a:solidFill>
+                  <a:srgbClr val="0D9B9B"/>
+                </a:solidFill>
+                <a:latin typeface="Microsoft JhengHei"/>
+              </a:rPr>
+              <a:t> cache？</a:t>
             </a:r>
           </a:p>
         </p:txBody>
@@ -17804,7 +18656,7 @@
         </p:nvSpPr>
         <p:spPr>
           <a:xfrm>
-            <a:off x="822960" y="4983480"/>
+            <a:off x="805031" y="5212080"/>
             <a:ext cx="10972800" cy="777240"/>
           </a:xfrm>
           <a:prstGeom prst="rect">
@@ -17824,7 +18676,7 @@
               </a:lnSpc>
             </a:pPr>
             <a:r>
-              <a:rPr sz="1600" b="1">
+              <a:rPr sz="1600" b="1" dirty="0">
                 <a:solidFill>
                   <a:srgbClr val="0D9B9B"/>
                 </a:solidFill>
@@ -17833,13 +18685,22 @@
               <a:t>▸  </a:t>
             </a:r>
             <a:r>
-              <a:rPr sz="1600">
+              <a:rPr sz="1600" dirty="0" err="1">
                 <a:solidFill>
                   <a:srgbClr val="1A1A2E"/>
                 </a:solidFill>
                 <a:latin typeface="Microsoft JhengHei"/>
               </a:rPr>
-              <a:t>讀檔案、API request</a:t>
+              <a:t>讀檔案、API</a:t>
+            </a:r>
+            <a:r>
+              <a:rPr sz="1600" dirty="0">
+                <a:solidFill>
+                  <a:srgbClr val="1A1A2E"/>
+                </a:solidFill>
+                <a:latin typeface="Microsoft JhengHei"/>
+              </a:rPr>
+              <a:t> request</a:t>
             </a:r>
           </a:p>
           <a:p>
@@ -17852,7 +18713,7 @@
               </a:spcBef>
             </a:pPr>
             <a:r>
-              <a:rPr sz="1600" b="1">
+              <a:rPr sz="1600" b="1" dirty="0">
                 <a:solidFill>
                   <a:srgbClr val="0D9B9B"/>
                 </a:solidFill>
@@ -17861,14 +18722,38 @@
               <a:t>▸  </a:t>
             </a:r>
             <a:r>
-              <a:rPr sz="1600">
+              <a:rPr sz="1600" dirty="0" err="1">
                 <a:solidFill>
                   <a:srgbClr val="1A1A2E"/>
                 </a:solidFill>
                 <a:latin typeface="Microsoft JhengHei"/>
               </a:rPr>
-              <a:t>同樣輸入永遠回同樣結果且耗時 &gt; 50 ms</a:t>
-            </a:r>
+              <a:t>同樣輸入永遠回同樣結果且耗時</a:t>
+            </a:r>
+            <a:r>
+              <a:rPr sz="1600" dirty="0">
+                <a:solidFill>
+                  <a:srgbClr val="1A1A2E"/>
+                </a:solidFill>
+                <a:latin typeface="Microsoft JhengHei"/>
+              </a:rPr>
+              <a:t> &gt; 50 </a:t>
+            </a:r>
+            <a:r>
+              <a:rPr sz="1600" dirty="0" err="1">
+                <a:solidFill>
+                  <a:srgbClr val="1A1A2E"/>
+                </a:solidFill>
+                <a:latin typeface="Microsoft JhengHei"/>
+              </a:rPr>
+              <a:t>ms</a:t>
+            </a:r>
+            <a:endParaRPr sz="1600" dirty="0">
+              <a:solidFill>
+                <a:srgbClr val="1A1A2E"/>
+              </a:solidFill>
+              <a:latin typeface="Microsoft JhengHei"/>
+            </a:endParaRPr>
           </a:p>
         </p:txBody>
       </p:sp>
@@ -17982,6 +18867,18 @@
   <p:clrMapOvr>
     <a:masterClrMapping/>
   </p:clrMapOvr>
+  <mc:AlternateContent xmlns:mc="http://schemas.openxmlformats.org/markup-compatibility/2006">
+    <mc:Choice xmlns:p14="http://schemas.microsoft.com/office/powerpoint/2010/main" Requires="p14">
+      <p:transition spd="slow" p14:dur="2000">
+        <p:cut/>
+      </p:transition>
+    </mc:Choice>
+    <mc:Fallback>
+      <p:transition spd="slow">
+        <p:cut/>
+      </p:transition>
+    </mc:Fallback>
+  </mc:AlternateContent>
 </p:sld>
 </file>
 
@@ -18745,6 +19642,18 @@
   <p:clrMapOvr>
     <a:masterClrMapping/>
   </p:clrMapOvr>
+  <mc:AlternateContent xmlns:mc="http://schemas.openxmlformats.org/markup-compatibility/2006">
+    <mc:Choice xmlns:p14="http://schemas.microsoft.com/office/powerpoint/2010/main" Requires="p14">
+      <p:transition spd="slow" p14:dur="2000">
+        <p:cut/>
+      </p:transition>
+    </mc:Choice>
+    <mc:Fallback>
+      <p:transition spd="slow">
+        <p:cut/>
+      </p:transition>
+    </mc:Fallback>
+  </mc:AlternateContent>
 </p:sld>
 </file>
 
@@ -19374,6 +20283,18 @@
   <p:clrMapOvr>
     <a:masterClrMapping/>
   </p:clrMapOvr>
+  <mc:AlternateContent xmlns:mc="http://schemas.openxmlformats.org/markup-compatibility/2006">
+    <mc:Choice xmlns:p14="http://schemas.microsoft.com/office/powerpoint/2010/main" Requires="p14">
+      <p:transition spd="slow" p14:dur="2000">
+        <p:cut/>
+      </p:transition>
+    </mc:Choice>
+    <mc:Fallback>
+      <p:transition spd="slow">
+        <p:cut/>
+      </p:transition>
+    </mc:Fallback>
+  </mc:AlternateContent>
 </p:sld>
 </file>
 
@@ -20112,6 +21033,18 @@
   <p:clrMapOvr>
     <a:masterClrMapping/>
   </p:clrMapOvr>
+  <mc:AlternateContent xmlns:mc="http://schemas.openxmlformats.org/markup-compatibility/2006">
+    <mc:Choice xmlns:p14="http://schemas.microsoft.com/office/powerpoint/2010/main" Requires="p14">
+      <p:transition spd="slow" p14:dur="2000">
+        <p:cut/>
+      </p:transition>
+    </mc:Choice>
+    <mc:Fallback>
+      <p:transition spd="slow">
+        <p:cut/>
+      </p:transition>
+    </mc:Fallback>
+  </mc:AlternateContent>
 </p:sld>
 </file>
 
@@ -20321,6 +21254,18 @@
   <p:clrMapOvr>
     <a:masterClrMapping/>
   </p:clrMapOvr>
+  <mc:AlternateContent xmlns:mc="http://schemas.openxmlformats.org/markup-compatibility/2006">
+    <mc:Choice xmlns:p14="http://schemas.microsoft.com/office/powerpoint/2010/main" Requires="p14">
+      <p:transition spd="slow" p14:dur="2000">
+        <p:cut/>
+      </p:transition>
+    </mc:Choice>
+    <mc:Fallback>
+      <p:transition spd="slow">
+        <p:cut/>
+      </p:transition>
+    </mc:Fallback>
+  </mc:AlternateContent>
 </p:sld>
 </file>
 
@@ -21769,6 +22714,18 @@
   <p:clrMapOvr>
     <a:masterClrMapping/>
   </p:clrMapOvr>
+  <mc:AlternateContent xmlns:mc="http://schemas.openxmlformats.org/markup-compatibility/2006">
+    <mc:Choice xmlns:p14="http://schemas.microsoft.com/office/powerpoint/2010/main" Requires="p14">
+      <p:transition spd="slow" p14:dur="2000">
+        <p:cut/>
+      </p:transition>
+    </mc:Choice>
+    <mc:Fallback>
+      <p:transition spd="slow">
+        <p:cut/>
+      </p:transition>
+    </mc:Fallback>
+  </mc:AlternateContent>
 </p:sld>
 </file>
 
@@ -22513,6 +23470,18 @@
   <p:clrMapOvr>
     <a:masterClrMapping/>
   </p:clrMapOvr>
+  <mc:AlternateContent xmlns:mc="http://schemas.openxmlformats.org/markup-compatibility/2006">
+    <mc:Choice xmlns:p14="http://schemas.microsoft.com/office/powerpoint/2010/main" Requires="p14">
+      <p:transition spd="slow" p14:dur="2000">
+        <p:cut/>
+      </p:transition>
+    </mc:Choice>
+    <mc:Fallback>
+      <p:transition spd="slow">
+        <p:cut/>
+      </p:transition>
+    </mc:Fallback>
+  </mc:AlternateContent>
 </p:sld>
 </file>
 
@@ -23322,6 +24291,18 @@
   <p:clrMapOvr>
     <a:masterClrMapping/>
   </p:clrMapOvr>
+  <mc:AlternateContent xmlns:mc="http://schemas.openxmlformats.org/markup-compatibility/2006">
+    <mc:Choice xmlns:p14="http://schemas.microsoft.com/office/powerpoint/2010/main" Requires="p14">
+      <p:transition spd="slow" p14:dur="2000">
+        <p:cut/>
+      </p:transition>
+    </mc:Choice>
+    <mc:Fallback>
+      <p:transition spd="slow">
+        <p:cut/>
+      </p:transition>
+    </mc:Fallback>
+  </mc:AlternateContent>
 </p:sld>
 </file>
 
@@ -24195,6 +25176,18 @@
   <p:clrMapOvr>
     <a:masterClrMapping/>
   </p:clrMapOvr>
+  <mc:AlternateContent xmlns:mc="http://schemas.openxmlformats.org/markup-compatibility/2006">
+    <mc:Choice xmlns:p14="http://schemas.microsoft.com/office/powerpoint/2010/main" Requires="p14">
+      <p:transition spd="slow" p14:dur="2000">
+        <p:cut/>
+      </p:transition>
+    </mc:Choice>
+    <mc:Fallback>
+      <p:transition spd="slow">
+        <p:cut/>
+      </p:transition>
+    </mc:Fallback>
+  </mc:AlternateContent>
 </p:sld>
 </file>
 
@@ -24404,6 +25397,18 @@
   <p:clrMapOvr>
     <a:masterClrMapping/>
   </p:clrMapOvr>
+  <mc:AlternateContent xmlns:mc="http://schemas.openxmlformats.org/markup-compatibility/2006">
+    <mc:Choice xmlns:p14="http://schemas.microsoft.com/office/powerpoint/2010/main" Requires="p14">
+      <p:transition spd="slow" p14:dur="2000">
+        <p:cut/>
+      </p:transition>
+    </mc:Choice>
+    <mc:Fallback>
+      <p:transition spd="slow">
+        <p:cut/>
+      </p:transition>
+    </mc:Fallback>
+  </mc:AlternateContent>
 </p:sld>
 </file>
 
@@ -25301,6 +26306,18 @@
   <p:clrMapOvr>
     <a:masterClrMapping/>
   </p:clrMapOvr>
+  <mc:AlternateContent xmlns:mc="http://schemas.openxmlformats.org/markup-compatibility/2006">
+    <mc:Choice xmlns:p14="http://schemas.microsoft.com/office/powerpoint/2010/main" Requires="p14">
+      <p:transition spd="slow" p14:dur="2000">
+        <p:cut/>
+      </p:transition>
+    </mc:Choice>
+    <mc:Fallback>
+      <p:transition spd="slow">
+        <p:cut/>
+      </p:transition>
+    </mc:Fallback>
+  </mc:AlternateContent>
 </p:sld>
 </file>
 
@@ -26427,6 +27444,18 @@
   <p:clrMapOvr>
     <a:masterClrMapping/>
   </p:clrMapOvr>
+  <mc:AlternateContent xmlns:mc="http://schemas.openxmlformats.org/markup-compatibility/2006">
+    <mc:Choice xmlns:p14="http://schemas.microsoft.com/office/powerpoint/2010/main" Requires="p14">
+      <p:transition spd="slow" p14:dur="2000">
+        <p:cut/>
+      </p:transition>
+    </mc:Choice>
+    <mc:Fallback>
+      <p:transition spd="slow">
+        <p:cut/>
+      </p:transition>
+    </mc:Fallback>
+  </mc:AlternateContent>
 </p:sld>
 </file>
 
@@ -26636,6 +27665,18 @@
   <p:clrMapOvr>
     <a:masterClrMapping/>
   </p:clrMapOvr>
+  <mc:AlternateContent xmlns:mc="http://schemas.openxmlformats.org/markup-compatibility/2006">
+    <mc:Choice xmlns:p14="http://schemas.microsoft.com/office/powerpoint/2010/main" Requires="p14">
+      <p:transition spd="slow" p14:dur="2000">
+        <p:cut/>
+      </p:transition>
+    </mc:Choice>
+    <mc:Fallback>
+      <p:transition spd="slow">
+        <p:cut/>
+      </p:transition>
+    </mc:Fallback>
+  </mc:AlternateContent>
 </p:sld>
 </file>
 
@@ -27294,6 +28335,18 @@
   <p:clrMapOvr>
     <a:masterClrMapping/>
   </p:clrMapOvr>
+  <mc:AlternateContent xmlns:mc="http://schemas.openxmlformats.org/markup-compatibility/2006">
+    <mc:Choice xmlns:p14="http://schemas.microsoft.com/office/powerpoint/2010/main" Requires="p14">
+      <p:transition spd="slow" p14:dur="2000">
+        <p:cut/>
+      </p:transition>
+    </mc:Choice>
+    <mc:Fallback>
+      <p:transition spd="slow">
+        <p:cut/>
+      </p:transition>
+    </mc:Fallback>
+  </mc:AlternateContent>
 </p:sld>
 </file>
 
@@ -27838,6 +28891,18 @@
   <p:clrMapOvr>
     <a:masterClrMapping/>
   </p:clrMapOvr>
+  <mc:AlternateContent xmlns:mc="http://schemas.openxmlformats.org/markup-compatibility/2006">
+    <mc:Choice xmlns:p14="http://schemas.microsoft.com/office/powerpoint/2010/main" Requires="p14">
+      <p:transition spd="slow" p14:dur="2000">
+        <p:cut/>
+      </p:transition>
+    </mc:Choice>
+    <mc:Fallback>
+      <p:transition spd="slow">
+        <p:cut/>
+      </p:transition>
+    </mc:Fallback>
+  </mc:AlternateContent>
 </p:sld>
 </file>
 

</xml_diff>